<commit_message>
Publish v1.4 presentation with honest 58.3%, 100% and 35% evaluation findings
</commit_message>
<xml_diff>
--- a/submission/TrustBoundary_Hackathon_Pitch.pptx
+++ b/submission/TrustBoundary_Hackathon_Pitch.pptx
@@ -3420,7 +3420,7 @@
               </a:defRPr>
             </a:pPr>
             <a:r>
-              <a:t>v1.2 · F3–D1 · SYNTHETIC SANDBOX</a:t>
+              <a:t>v1.4 · F3–D1 · SYNTHETIC SANDBOX</a:t>
             </a:r>
           </a:p>
         </p:txBody>
@@ -3515,6 +3515,45 @@
         </p:nvSpPr>
         <p:spPr>
           <a:xfrm>
+            <a:off x="987552" y="4974336"/>
+            <a:ext cx="9144000" cy="347472"/>
+          </a:xfrm>
+          <a:prstGeom prst="rect">
+            <a:avLst/>
+          </a:prstGeom>
+          <a:noFill/>
+        </p:spPr>
+        <p:txBody>
+          <a:bodyPr wrap="square" lIns="36576" tIns="9144" rIns="36576" bIns="9144">
+            <a:spAutoFit/>
+          </a:bodyPr>
+          <a:lstStyle/>
+          <a:p>
+            <a:pPr>
+              <a:spcAft>
+                <a:spcPts val="100"/>
+              </a:spcAft>
+              <a:defRPr sz="1500" b="0">
+                <a:solidFill>
+                  <a:srgbClr val="9BB0C8"/>
+                </a:solidFill>
+                <a:latin typeface="Aptos"/>
+              </a:defRPr>
+            </a:pPr>
+            <a:r>
+              <a:t>Participant: Dhinesh Babu Venkatesan</a:t>
+            </a:r>
+          </a:p>
+        </p:txBody>
+      </p:sp>
+      <p:sp>
+        <p:nvSpPr>
+          <p:cNvPr id="13" name="TextBox 12"/>
+          <p:cNvSpPr txBox="1"/>
+          <p:nvPr/>
+        </p:nvSpPr>
+        <p:spPr>
+          <a:xfrm>
             <a:off x="9829800" y="2560320"/>
             <a:ext cx="914400" cy="758952"/>
           </a:xfrm>
@@ -3548,7 +3587,7 @@
       </p:sp>
       <p:sp>
         <p:nvSpPr>
-          <p:cNvPr id="13" name="TextBox 12"/>
+          <p:cNvPr id="14" name="TextBox 13"/>
           <p:cNvSpPr txBox="1"/>
           <p:nvPr/>
         </p:nvSpPr>
@@ -3587,7 +3626,7 @@
       </p:sp>
       <p:sp>
         <p:nvSpPr>
-          <p:cNvPr id="14" name="TextBox 13"/>
+          <p:cNvPr id="15" name="TextBox 14"/>
           <p:cNvSpPr txBox="1"/>
           <p:nvPr/>
         </p:nvSpPr>
@@ -3805,7 +3844,7 @@
               </a:defRPr>
             </a:pPr>
             <a:r>
-              <a:t>Ready to demonstrate. Honest about the next steps.</a:t>
+              <a:t>Runnable, measurable, and clear about limitations.</a:t>
             </a:r>
           </a:p>
         </p:txBody>
@@ -3965,7 +4004,7 @@
               </a:defRPr>
             </a:pPr>
             <a:r>
-              <a:t>v1.2 · F3–D1 · SYNTHETIC SANDBOX</a:t>
+              <a:t>v1.4 · F3–D1 · SYNTHETIC SANDBOX</a:t>
             </a:r>
           </a:p>
         </p:txBody>
@@ -4207,7 +4246,7 @@
               </a:defRPr>
             </a:pPr>
             <a:r>
-              <a:t>External adversarial corpus, LLM red-team runs, real identity/approval integration.</a:t>
+              <a:t>Independent testing and live OpenAI evaluation; fresh 40-case recall only 35.0%.</a:t>
             </a:r>
           </a:p>
         </p:txBody>
@@ -4336,6 +4375,45 @@
       <p:sp>
         <p:nvSpPr>
           <p:cNvPr id="19" name="TextBox 18"/>
+          <p:cNvSpPr txBox="1"/>
+          <p:nvPr/>
+        </p:nvSpPr>
+        <p:spPr>
+          <a:xfrm>
+            <a:off x="786384" y="5568696"/>
+            <a:ext cx="10835640" cy="347472"/>
+          </a:xfrm>
+          <a:prstGeom prst="rect">
+            <a:avLst/>
+          </a:prstGeom>
+          <a:noFill/>
+        </p:spPr>
+        <p:txBody>
+          <a:bodyPr wrap="square" lIns="36576" tIns="9144" rIns="36576" bIns="9144">
+            <a:spAutoFit/>
+          </a:bodyPr>
+          <a:lstStyle/>
+          <a:p>
+            <a:pPr>
+              <a:spcAft>
+                <a:spcPts val="100"/>
+              </a:spcAft>
+              <a:defRPr sz="1500" b="1">
+                <a:solidFill>
+                  <a:srgbClr val="9BB0C8"/>
+                </a:solidFill>
+                <a:latin typeface="Aptos"/>
+              </a:defRPr>
+            </a:pPr>
+            <a:r>
+              <a:t>Repository: github.com/saidhinu/TrustBoundary-AI-Agentic-Security</a:t>
+            </a:r>
+          </a:p>
+        </p:txBody>
+      </p:sp>
+      <p:sp>
+        <p:nvSpPr>
+          <p:cNvPr id="20" name="TextBox 19"/>
           <p:cNvSpPr txBox="1"/>
           <p:nvPr/>
         </p:nvSpPr>
@@ -4713,7 +4791,7 @@
               </a:defRPr>
             </a:pPr>
             <a:r>
-              <a:t>v1.2 · F3–D1 · SYNTHETIC SANDBOX</a:t>
+              <a:t>v1.4 · F3–D1 · SYNTHETIC SANDBOX</a:t>
             </a:r>
           </a:p>
         </p:txBody>
@@ -5578,7 +5656,7 @@
               </a:defRPr>
             </a:pPr>
             <a:r>
-              <a:t>v1.2 · F3–D1 · SYNTHETIC SANDBOX</a:t>
+              <a:t>v1.4 · F3–D1 · SYNTHETIC SANDBOX</a:t>
             </a:r>
           </a:p>
         </p:txBody>
@@ -6447,7 +6525,7 @@
               </a:defRPr>
             </a:pPr>
             <a:r>
-              <a:t>v1.2 · F3–D1 · SYNTHETIC SANDBOX</a:t>
+              <a:t>v1.4 · F3–D1 · SYNTHETIC SANDBOX</a:t>
             </a:r>
           </a:p>
         </p:txBody>
@@ -6978,7 +7056,7 @@
               </a:defRPr>
             </a:pPr>
             <a:r>
-              <a:t>v1.2 · F3–D1 · SYNTHETIC SANDBOX</a:t>
+              <a:t>v1.4 · F3–D1 · SYNTHETIC SANDBOX</a:t>
             </a:r>
           </a:p>
         </p:txBody>
@@ -8409,7 +8487,7 @@
               </a:defRPr>
             </a:pPr>
             <a:r>
-              <a:t>v1.2 · F3–D1 · SYNTHETIC SANDBOX</a:t>
+              <a:t>v1.4 · F3–D1 · SYNTHETIC SANDBOX</a:t>
             </a:r>
           </a:p>
         </p:txBody>
@@ -9723,7 +9801,7 @@
               </a:defRPr>
             </a:pPr>
             <a:r>
-              <a:t>Synthetic holdout: reproducible, not production validation.</a:t>
+              <a:t>Safety evaluation: results depend on the test distribution.</a:t>
             </a:r>
           </a:p>
         </p:txBody>
@@ -9762,7 +9840,7 @@
               </a:defRPr>
             </a:pPr>
             <a:r>
-              <a:t>Local hybrid detector measured against 80 synthetic held-out examples, with transparent caveats.</a:t>
+              <a:t>A known-case retest is not independent evidence; the fresh 40-case result remains weak.</a:t>
             </a:r>
           </a:p>
         </p:txBody>
@@ -9883,7 +9961,7 @@
               </a:defRPr>
             </a:pPr>
             <a:r>
-              <a:t>v1.2 · F3–D1 · SYNTHETIC SANDBOX</a:t>
+              <a:t>v1.4 · F3–D1 · SYNTHETIC SANDBOX</a:t>
             </a:r>
           </a:p>
         </p:txBody>
@@ -9896,8 +9974,8 @@
         </p:nvSpPr>
         <p:spPr>
           <a:xfrm>
-            <a:off x="685800" y="2167128"/>
-            <a:ext cx="2615184" cy="1819656"/>
+            <a:off x="685800" y="2377440"/>
+            <a:ext cx="3611880" cy="2670048"/>
           </a:xfrm>
           <a:prstGeom prst="roundRect">
             <a:avLst/>
@@ -9939,25 +10017,25 @@
         </p:nvSpPr>
         <p:spPr>
           <a:xfrm>
-            <a:off x="868680" y="2350008"/>
-            <a:ext cx="2295144" cy="246888"/>
-          </a:xfrm>
-          <a:prstGeom prst="rect">
-            <a:avLst/>
-          </a:prstGeom>
-          <a:noFill/>
-        </p:spPr>
-        <p:txBody>
-          <a:bodyPr wrap="square" lIns="36576" tIns="9144" rIns="36576" bIns="9144">
-            <a:spAutoFit/>
-          </a:bodyPr>
-          <a:lstStyle/>
-          <a:p>
-            <a:pPr>
-              <a:spcAft>
-                <a:spcPts val="100"/>
-              </a:spcAft>
-              <a:defRPr sz="1000" b="1">
+            <a:off x="868680" y="2642616"/>
+            <a:ext cx="3273552" cy="310896"/>
+          </a:xfrm>
+          <a:prstGeom prst="rect">
+            <a:avLst/>
+          </a:prstGeom>
+          <a:noFill/>
+        </p:spPr>
+        <p:txBody>
+          <a:bodyPr wrap="square" lIns="36576" tIns="9144" rIns="36576" bIns="9144">
+            <a:spAutoFit/>
+          </a:bodyPr>
+          <a:lstStyle/>
+          <a:p>
+            <a:pPr>
+              <a:spcAft>
+                <a:spcPts val="100"/>
+              </a:spcAft>
+              <a:defRPr sz="1300" b="1">
                 <a:solidFill>
                   <a:srgbClr val="9BB0C8"/>
                 </a:solidFill>
@@ -9965,7 +10043,7 @@
               </a:defRPr>
             </a:pPr>
             <a:r>
-              <a:t>ATTACKS</a:t>
+              <a:t>PRE-FIX BASELINE</a:t>
             </a:r>
           </a:p>
         </p:txBody>
@@ -9978,33 +10056,33 @@
         </p:nvSpPr>
         <p:spPr>
           <a:xfrm>
-            <a:off x="859536" y="2670048"/>
-            <a:ext cx="2295144" cy="530352"/>
-          </a:xfrm>
-          <a:prstGeom prst="rect">
-            <a:avLst/>
-          </a:prstGeom>
-          <a:noFill/>
-        </p:spPr>
-        <p:txBody>
-          <a:bodyPr wrap="square" lIns="36576" tIns="9144" rIns="36576" bIns="9144">
-            <a:spAutoFit/>
-          </a:bodyPr>
-          <a:lstStyle/>
-          <a:p>
-            <a:pPr>
-              <a:spcAft>
-                <a:spcPts val="100"/>
-              </a:spcAft>
-              <a:defRPr sz="2600" b="1">
-                <a:solidFill>
-                  <a:srgbClr val="39D9B0"/>
-                </a:solidFill>
-                <a:latin typeface="Aptos"/>
-              </a:defRPr>
-            </a:pPr>
-            <a:r>
-              <a:t>45</a:t>
+            <a:off x="868680" y="3118104"/>
+            <a:ext cx="3255264" cy="640080"/>
+          </a:xfrm>
+          <a:prstGeom prst="rect">
+            <a:avLst/>
+          </a:prstGeom>
+          <a:noFill/>
+        </p:spPr>
+        <p:txBody>
+          <a:bodyPr wrap="square" lIns="36576" tIns="9144" rIns="36576" bIns="9144">
+            <a:spAutoFit/>
+          </a:bodyPr>
+          <a:lstStyle/>
+          <a:p>
+            <a:pPr>
+              <a:spcAft>
+                <a:spcPts val="100"/>
+              </a:spcAft>
+              <a:defRPr sz="3700" b="1">
+                <a:solidFill>
+                  <a:srgbClr val="FF8189"/>
+                </a:solidFill>
+                <a:latin typeface="Aptos"/>
+              </a:defRPr>
+            </a:pPr>
+            <a:r>
+              <a:t>58.3%</a:t>
             </a:r>
           </a:p>
         </p:txBody>
@@ -10017,25 +10095,25 @@
         </p:nvSpPr>
         <p:spPr>
           <a:xfrm>
-            <a:off x="859536" y="3264408"/>
-            <a:ext cx="2295144" cy="630936"/>
-          </a:xfrm>
-          <a:prstGeom prst="rect">
-            <a:avLst/>
-          </a:prstGeom>
-          <a:noFill/>
-        </p:spPr>
-        <p:txBody>
-          <a:bodyPr wrap="square" lIns="36576" tIns="9144" rIns="36576" bIns="9144">
-            <a:spAutoFit/>
-          </a:bodyPr>
-          <a:lstStyle/>
-          <a:p>
-            <a:pPr>
-              <a:spcAft>
-                <a:spcPts val="100"/>
-              </a:spcAft>
-              <a:defRPr sz="1100" b="0">
+            <a:off x="868680" y="3858768"/>
+            <a:ext cx="3255264" cy="310896"/>
+          </a:xfrm>
+          <a:prstGeom prst="rect">
+            <a:avLst/>
+          </a:prstGeom>
+          <a:noFill/>
+        </p:spPr>
+        <p:txBody>
+          <a:bodyPr wrap="square" lIns="36576" tIns="9144" rIns="36576" bIns="9144">
+            <a:spAutoFit/>
+          </a:bodyPr>
+          <a:lstStyle/>
+          <a:p>
+            <a:pPr>
+              <a:spcAft>
+                <a:spcPts val="100"/>
+              </a:spcAft>
+              <a:defRPr sz="1500" b="1">
                 <a:solidFill>
                   <a:srgbClr val="EEF7FF"/>
                 </a:solidFill>
@@ -10043,21 +10121,60 @@
               </a:defRPr>
             </a:pPr>
             <a:r>
-              <a:t>test examples</a:t>
-            </a:r>
-          </a:p>
-        </p:txBody>
-      </p:sp>
-      <p:sp>
-        <p:nvSpPr>
-          <p:cNvPr id="14" name="Rounded Rectangle 13"/>
+              <a:t>14 / 24 attacks detected</a:t>
+            </a:r>
+          </a:p>
+        </p:txBody>
+      </p:sp>
+      <p:sp>
+        <p:nvSpPr>
+          <p:cNvPr id="14" name="TextBox 13"/>
+          <p:cNvSpPr txBox="1"/>
+          <p:nvPr/>
+        </p:nvSpPr>
+        <p:spPr>
+          <a:xfrm>
+            <a:off x="868680" y="4297680"/>
+            <a:ext cx="3200400" cy="502920"/>
+          </a:xfrm>
+          <a:prstGeom prst="rect">
+            <a:avLst/>
+          </a:prstGeom>
+          <a:noFill/>
+        </p:spPr>
+        <p:txBody>
+          <a:bodyPr wrap="square" lIns="36576" tIns="9144" rIns="36576" bIns="9144">
+            <a:spAutoFit/>
+          </a:bodyPr>
+          <a:lstStyle/>
+          <a:p>
+            <a:pPr>
+              <a:spcAft>
+                <a:spcPts val="100"/>
+              </a:spcAft>
+              <a:defRPr sz="1200" b="0">
+                <a:solidFill>
+                  <a:srgbClr val="9BB0C8"/>
+                </a:solidFill>
+                <a:latin typeface="Aptos"/>
+              </a:defRPr>
+            </a:pPr>
+            <a:r>
+              <a:t>42 known cases; 1 benign FP</a:t>
+            </a:r>
+          </a:p>
+        </p:txBody>
+      </p:sp>
+      <p:sp>
+        <p:nvSpPr>
+          <p:cNvPr id="15" name="Rounded Rectangle 14"/>
           <p:cNvSpPr/>
           <p:nvPr/>
         </p:nvSpPr>
         <p:spPr>
           <a:xfrm>
-            <a:off x="3557016" y="2167128"/>
-            <a:ext cx="2615184" cy="1819656"/>
+            <a:off x="4572000" y="2377440"/>
+            <a:ext cx="3611880" cy="2670048"/>
           </a:xfrm>
           <a:prstGeom prst="roundRect">
             <a:avLst/>
@@ -10093,31 +10210,31 @@
       </p:sp>
       <p:sp>
         <p:nvSpPr>
-          <p:cNvPr id="15" name="TextBox 14"/>
-          <p:cNvSpPr txBox="1"/>
-          <p:nvPr/>
-        </p:nvSpPr>
-        <p:spPr>
-          <a:xfrm>
-            <a:off x="3739896" y="2350008"/>
-            <a:ext cx="2295144" cy="246888"/>
-          </a:xfrm>
-          <a:prstGeom prst="rect">
-            <a:avLst/>
-          </a:prstGeom>
-          <a:noFill/>
-        </p:spPr>
-        <p:txBody>
-          <a:bodyPr wrap="square" lIns="36576" tIns="9144" rIns="36576" bIns="9144">
-            <a:spAutoFit/>
-          </a:bodyPr>
-          <a:lstStyle/>
-          <a:p>
-            <a:pPr>
-              <a:spcAft>
-                <a:spcPts val="100"/>
-              </a:spcAft>
-              <a:defRPr sz="1000" b="1">
+          <p:cNvPr id="16" name="TextBox 15"/>
+          <p:cNvSpPr txBox="1"/>
+          <p:nvPr/>
+        </p:nvSpPr>
+        <p:spPr>
+          <a:xfrm>
+            <a:off x="4754880" y="2642616"/>
+            <a:ext cx="3273552" cy="310896"/>
+          </a:xfrm>
+          <a:prstGeom prst="rect">
+            <a:avLst/>
+          </a:prstGeom>
+          <a:noFill/>
+        </p:spPr>
+        <p:txBody>
+          <a:bodyPr wrap="square" lIns="36576" tIns="9144" rIns="36576" bIns="9144">
+            <a:spAutoFit/>
+          </a:bodyPr>
+          <a:lstStyle/>
+          <a:p>
+            <a:pPr>
+              <a:spcAft>
+                <a:spcPts val="100"/>
+              </a:spcAft>
+              <a:defRPr sz="1300" b="1">
                 <a:solidFill>
                   <a:srgbClr val="9BB0C8"/>
                 </a:solidFill>
@@ -10125,46 +10242,7 @@
               </a:defRPr>
             </a:pPr>
             <a:r>
-              <a:t>BENIGN / QUOTED</a:t>
-            </a:r>
-          </a:p>
-        </p:txBody>
-      </p:sp>
-      <p:sp>
-        <p:nvSpPr>
-          <p:cNvPr id="16" name="TextBox 15"/>
-          <p:cNvSpPr txBox="1"/>
-          <p:nvPr/>
-        </p:nvSpPr>
-        <p:spPr>
-          <a:xfrm>
-            <a:off x="3730752" y="2670048"/>
-            <a:ext cx="2295144" cy="530352"/>
-          </a:xfrm>
-          <a:prstGeom prst="rect">
-            <a:avLst/>
-          </a:prstGeom>
-          <a:noFill/>
-        </p:spPr>
-        <p:txBody>
-          <a:bodyPr wrap="square" lIns="36576" tIns="9144" rIns="36576" bIns="9144">
-            <a:spAutoFit/>
-          </a:bodyPr>
-          <a:lstStyle/>
-          <a:p>
-            <a:pPr>
-              <a:spcAft>
-                <a:spcPts val="100"/>
-              </a:spcAft>
-              <a:defRPr sz="2600" b="1">
-                <a:solidFill>
-                  <a:srgbClr val="85A9FF"/>
-                </a:solidFill>
-                <a:latin typeface="Aptos"/>
-              </a:defRPr>
-            </a:pPr>
-            <a:r>
-              <a:t>35</a:t>
+              <a:t>FEEDBACK RETEST</a:t>
             </a:r>
           </a:p>
         </p:txBody>
@@ -10177,25 +10255,64 @@
         </p:nvSpPr>
         <p:spPr>
           <a:xfrm>
-            <a:off x="3730752" y="3264408"/>
-            <a:ext cx="2295144" cy="630936"/>
-          </a:xfrm>
-          <a:prstGeom prst="rect">
-            <a:avLst/>
-          </a:prstGeom>
-          <a:noFill/>
-        </p:spPr>
-        <p:txBody>
-          <a:bodyPr wrap="square" lIns="36576" tIns="9144" rIns="36576" bIns="9144">
-            <a:spAutoFit/>
-          </a:bodyPr>
-          <a:lstStyle/>
-          <a:p>
-            <a:pPr>
-              <a:spcAft>
-                <a:spcPts val="100"/>
-              </a:spcAft>
-              <a:defRPr sz="1100" b="0">
+            <a:off x="4754880" y="3118104"/>
+            <a:ext cx="3255264" cy="640080"/>
+          </a:xfrm>
+          <a:prstGeom prst="rect">
+            <a:avLst/>
+          </a:prstGeom>
+          <a:noFill/>
+        </p:spPr>
+        <p:txBody>
+          <a:bodyPr wrap="square" lIns="36576" tIns="9144" rIns="36576" bIns="9144">
+            <a:spAutoFit/>
+          </a:bodyPr>
+          <a:lstStyle/>
+          <a:p>
+            <a:pPr>
+              <a:spcAft>
+                <a:spcPts val="100"/>
+              </a:spcAft>
+              <a:defRPr sz="3700" b="1">
+                <a:solidFill>
+                  <a:srgbClr val="39D9B0"/>
+                </a:solidFill>
+                <a:latin typeface="Aptos"/>
+              </a:defRPr>
+            </a:pPr>
+            <a:r>
+              <a:t>100.0%</a:t>
+            </a:r>
+          </a:p>
+        </p:txBody>
+      </p:sp>
+      <p:sp>
+        <p:nvSpPr>
+          <p:cNvPr id="18" name="TextBox 17"/>
+          <p:cNvSpPr txBox="1"/>
+          <p:nvPr/>
+        </p:nvSpPr>
+        <p:spPr>
+          <a:xfrm>
+            <a:off x="4754880" y="3858768"/>
+            <a:ext cx="3255264" cy="310896"/>
+          </a:xfrm>
+          <a:prstGeom prst="rect">
+            <a:avLst/>
+          </a:prstGeom>
+          <a:noFill/>
+        </p:spPr>
+        <p:txBody>
+          <a:bodyPr wrap="square" lIns="36576" tIns="9144" rIns="36576" bIns="9144">
+            <a:spAutoFit/>
+          </a:bodyPr>
+          <a:lstStyle/>
+          <a:p>
+            <a:pPr>
+              <a:spcAft>
+                <a:spcPts val="100"/>
+              </a:spcAft>
+              <a:defRPr sz="1500" b="1">
                 <a:solidFill>
                   <a:srgbClr val="EEF7FF"/>
                 </a:solidFill>
@@ -10203,21 +10320,60 @@
               </a:defRPr>
             </a:pPr>
             <a:r>
-              <a:t>test examples</a:t>
-            </a:r>
-          </a:p>
-        </p:txBody>
-      </p:sp>
-      <p:sp>
-        <p:nvSpPr>
-          <p:cNvPr id="18" name="Rounded Rectangle 17"/>
+              <a:t>30 / 30 attacks detected</a:t>
+            </a:r>
+          </a:p>
+        </p:txBody>
+      </p:sp>
+      <p:sp>
+        <p:nvSpPr>
+          <p:cNvPr id="19" name="TextBox 18"/>
+          <p:cNvSpPr txBox="1"/>
+          <p:nvPr/>
+        </p:nvSpPr>
+        <p:spPr>
+          <a:xfrm>
+            <a:off x="4754880" y="4297680"/>
+            <a:ext cx="3200400" cy="502920"/>
+          </a:xfrm>
+          <a:prstGeom prst="rect">
+            <a:avLst/>
+          </a:prstGeom>
+          <a:noFill/>
+        </p:spPr>
+        <p:txBody>
+          <a:bodyPr wrap="square" lIns="36576" tIns="9144" rIns="36576" bIns="9144">
+            <a:spAutoFit/>
+          </a:bodyPr>
+          <a:lstStyle/>
+          <a:p>
+            <a:pPr>
+              <a:spcAft>
+                <a:spcPts val="100"/>
+              </a:spcAft>
+              <a:defRPr sz="1200" b="0">
+                <a:solidFill>
+                  <a:srgbClr val="9BB0C8"/>
+                </a:solidFill>
+                <a:latin typeface="Aptos"/>
+              </a:defRPr>
+            </a:pPr>
+            <a:r>
+              <a:t>60 known cases, tuned to feedback</a:t>
+            </a:r>
+          </a:p>
+        </p:txBody>
+      </p:sp>
+      <p:sp>
+        <p:nvSpPr>
+          <p:cNvPr id="20" name="Rounded Rectangle 19"/>
           <p:cNvSpPr/>
           <p:nvPr/>
         </p:nvSpPr>
         <p:spPr>
           <a:xfrm>
-            <a:off x="6428232" y="2167128"/>
-            <a:ext cx="2615184" cy="1819656"/>
+            <a:off x="8458200" y="2377440"/>
+            <a:ext cx="3611880" cy="2670048"/>
           </a:xfrm>
           <a:prstGeom prst="roundRect">
             <a:avLst/>
@@ -10253,31 +10409,31 @@
       </p:sp>
       <p:sp>
         <p:nvSpPr>
-          <p:cNvPr id="19" name="TextBox 18"/>
-          <p:cNvSpPr txBox="1"/>
-          <p:nvPr/>
-        </p:nvSpPr>
-        <p:spPr>
-          <a:xfrm>
-            <a:off x="6611112" y="2350008"/>
-            <a:ext cx="2295144" cy="246888"/>
-          </a:xfrm>
-          <a:prstGeom prst="rect">
-            <a:avLst/>
-          </a:prstGeom>
-          <a:noFill/>
-        </p:spPr>
-        <p:txBody>
-          <a:bodyPr wrap="square" lIns="36576" tIns="9144" rIns="36576" bIns="9144">
-            <a:spAutoFit/>
-          </a:bodyPr>
-          <a:lstStyle/>
-          <a:p>
-            <a:pPr>
-              <a:spcAft>
-                <a:spcPts val="100"/>
-              </a:spcAft>
-              <a:defRPr sz="1000" b="1">
+          <p:cNvPr id="21" name="TextBox 20"/>
+          <p:cNvSpPr txBox="1"/>
+          <p:nvPr/>
+        </p:nvSpPr>
+        <p:spPr>
+          <a:xfrm>
+            <a:off x="8641080" y="2642616"/>
+            <a:ext cx="3273552" cy="310896"/>
+          </a:xfrm>
+          <a:prstGeom prst="rect">
+            <a:avLst/>
+          </a:prstGeom>
+          <a:noFill/>
+        </p:spPr>
+        <p:txBody>
+          <a:bodyPr wrap="square" lIns="36576" tIns="9144" rIns="36576" bIns="9144">
+            <a:spAutoFit/>
+          </a:bodyPr>
+          <a:lstStyle/>
+          <a:p>
+            <a:pPr>
+              <a:spcAft>
+                <a:spcPts val="100"/>
+              </a:spcAft>
+              <a:defRPr sz="1300" b="1">
                 <a:solidFill>
                   <a:srgbClr val="9BB0C8"/>
                 </a:solidFill>
@@ -10285,77 +10441,77 @@
               </a:defRPr>
             </a:pPr>
             <a:r>
-              <a:t>DETECTION RECALL</a:t>
-            </a:r>
-          </a:p>
-        </p:txBody>
-      </p:sp>
-      <p:sp>
-        <p:nvSpPr>
-          <p:cNvPr id="20" name="TextBox 19"/>
-          <p:cNvSpPr txBox="1"/>
-          <p:nvPr/>
-        </p:nvSpPr>
-        <p:spPr>
-          <a:xfrm>
-            <a:off x="6601968" y="2670048"/>
-            <a:ext cx="2295144" cy="530352"/>
-          </a:xfrm>
-          <a:prstGeom prst="rect">
-            <a:avLst/>
-          </a:prstGeom>
-          <a:noFill/>
-        </p:spPr>
-        <p:txBody>
-          <a:bodyPr wrap="square" lIns="36576" tIns="9144" rIns="36576" bIns="9144">
-            <a:spAutoFit/>
-          </a:bodyPr>
-          <a:lstStyle/>
-          <a:p>
-            <a:pPr>
-              <a:spcAft>
-                <a:spcPts val="100"/>
-              </a:spcAft>
-              <a:defRPr sz="2600" b="1">
-                <a:solidFill>
-                  <a:srgbClr val="39D9B0"/>
-                </a:solidFill>
-                <a:latin typeface="Aptos"/>
-              </a:defRPr>
-            </a:pPr>
-            <a:r>
-              <a:t>100%</a:t>
-            </a:r>
-          </a:p>
-        </p:txBody>
-      </p:sp>
-      <p:sp>
-        <p:nvSpPr>
-          <p:cNvPr id="21" name="TextBox 20"/>
-          <p:cNvSpPr txBox="1"/>
-          <p:nvPr/>
-        </p:nvSpPr>
-        <p:spPr>
-          <a:xfrm>
-            <a:off x="6601968" y="3264408"/>
-            <a:ext cx="2295144" cy="630936"/>
-          </a:xfrm>
-          <a:prstGeom prst="rect">
-            <a:avLst/>
-          </a:prstGeom>
-          <a:noFill/>
-        </p:spPr>
-        <p:txBody>
-          <a:bodyPr wrap="square" lIns="36576" tIns="9144" rIns="36576" bIns="9144">
-            <a:spAutoFit/>
-          </a:bodyPr>
-          <a:lstStyle/>
-          <a:p>
-            <a:pPr>
-              <a:spcAft>
-                <a:spcPts val="100"/>
-              </a:spcAft>
-              <a:defRPr sz="1100" b="0">
+              <a:t>NEW CHALLENGE</a:t>
+            </a:r>
+          </a:p>
+        </p:txBody>
+      </p:sp>
+      <p:sp>
+        <p:nvSpPr>
+          <p:cNvPr id="22" name="TextBox 21"/>
+          <p:cNvSpPr txBox="1"/>
+          <p:nvPr/>
+        </p:nvSpPr>
+        <p:spPr>
+          <a:xfrm>
+            <a:off x="8641080" y="3118104"/>
+            <a:ext cx="3255264" cy="640080"/>
+          </a:xfrm>
+          <a:prstGeom prst="rect">
+            <a:avLst/>
+          </a:prstGeom>
+          <a:noFill/>
+        </p:spPr>
+        <p:txBody>
+          <a:bodyPr wrap="square" lIns="36576" tIns="9144" rIns="36576" bIns="9144">
+            <a:spAutoFit/>
+          </a:bodyPr>
+          <a:lstStyle/>
+          <a:p>
+            <a:pPr>
+              <a:spcAft>
+                <a:spcPts val="100"/>
+              </a:spcAft>
+              <a:defRPr sz="3700" b="1">
+                <a:solidFill>
+                  <a:srgbClr val="F1C174"/>
+                </a:solidFill>
+                <a:latin typeface="Aptos"/>
+              </a:defRPr>
+            </a:pPr>
+            <a:r>
+              <a:t>35.0%</a:t>
+            </a:r>
+          </a:p>
+        </p:txBody>
+      </p:sp>
+      <p:sp>
+        <p:nvSpPr>
+          <p:cNvPr id="23" name="TextBox 22"/>
+          <p:cNvSpPr txBox="1"/>
+          <p:nvPr/>
+        </p:nvSpPr>
+        <p:spPr>
+          <a:xfrm>
+            <a:off x="8641080" y="3858768"/>
+            <a:ext cx="3255264" cy="310896"/>
+          </a:xfrm>
+          <a:prstGeom prst="rect">
+            <a:avLst/>
+          </a:prstGeom>
+          <a:noFill/>
+        </p:spPr>
+        <p:txBody>
+          <a:bodyPr wrap="square" lIns="36576" tIns="9144" rIns="36576" bIns="9144">
+            <a:spAutoFit/>
+          </a:bodyPr>
+          <a:lstStyle/>
+          <a:p>
+            <a:pPr>
+              <a:spcAft>
+                <a:spcPts val="100"/>
+              </a:spcAft>
+              <a:defRPr sz="1500" b="1">
                 <a:solidFill>
                   <a:srgbClr val="EEF7FF"/>
                 </a:solidFill>
@@ -10363,181 +10519,60 @@
               </a:defRPr>
             </a:pPr>
             <a:r>
-              <a:t>templated examples</a:t>
-            </a:r>
-          </a:p>
-        </p:txBody>
-      </p:sp>
-      <p:sp>
-        <p:nvSpPr>
-          <p:cNvPr id="22" name="Rounded Rectangle 21"/>
+              <a:t>7 / 20 attacks detected</a:t>
+            </a:r>
+          </a:p>
+        </p:txBody>
+      </p:sp>
+      <p:sp>
+        <p:nvSpPr>
+          <p:cNvPr id="24" name="TextBox 23"/>
+          <p:cNvSpPr txBox="1"/>
+          <p:nvPr/>
+        </p:nvSpPr>
+        <p:spPr>
+          <a:xfrm>
+            <a:off x="8641080" y="4297680"/>
+            <a:ext cx="3200400" cy="502920"/>
+          </a:xfrm>
+          <a:prstGeom prst="rect">
+            <a:avLst/>
+          </a:prstGeom>
+          <a:noFill/>
+        </p:spPr>
+        <p:txBody>
+          <a:bodyPr wrap="square" lIns="36576" tIns="9144" rIns="36576" bIns="9144">
+            <a:spAutoFit/>
+          </a:bodyPr>
+          <a:lstStyle/>
+          <a:p>
+            <a:pPr>
+              <a:spcAft>
+                <a:spcPts val="100"/>
+              </a:spcAft>
+              <a:defRPr sz="1200" b="0">
+                <a:solidFill>
+                  <a:srgbClr val="9BB0C8"/>
+                </a:solidFill>
+                <a:latin typeface="Aptos"/>
+              </a:defRPr>
+            </a:pPr>
+            <a:r>
+              <a:t>40 new authored cases; 1 benign FP</a:t>
+            </a:r>
+          </a:p>
+        </p:txBody>
+      </p:sp>
+      <p:sp>
+        <p:nvSpPr>
+          <p:cNvPr id="25" name="Rounded Rectangle 24"/>
           <p:cNvSpPr/>
           <p:nvPr/>
         </p:nvSpPr>
         <p:spPr>
           <a:xfrm>
-            <a:off x="9299448" y="2167128"/>
-            <a:ext cx="2615184" cy="1819656"/>
-          </a:xfrm>
-          <a:prstGeom prst="roundRect">
-            <a:avLst/>
-          </a:prstGeom>
-          <a:solidFill>
-            <a:srgbClr val="112238"/>
-          </a:solidFill>
-          <a:ln>
-            <a:noFill/>
-          </a:ln>
-        </p:spPr>
-        <p:style>
-          <a:lnRef idx="1">
-            <a:schemeClr val="accent1"/>
-          </a:lnRef>
-          <a:fillRef idx="3">
-            <a:schemeClr val="accent1"/>
-          </a:fillRef>
-          <a:effectRef idx="2">
-            <a:schemeClr val="accent1"/>
-          </a:effectRef>
-          <a:fontRef idx="minor">
-            <a:schemeClr val="lt1"/>
-          </a:fontRef>
-        </p:style>
-        <p:txBody>
-          <a:bodyPr rtlCol="0" anchor="ctr"/>
-          <a:lstStyle/>
-          <a:p>
-            <a:pPr algn="ctr"/>
-          </a:p>
-        </p:txBody>
-      </p:sp>
-      <p:sp>
-        <p:nvSpPr>
-          <p:cNvPr id="23" name="TextBox 22"/>
-          <p:cNvSpPr txBox="1"/>
-          <p:nvPr/>
-        </p:nvSpPr>
-        <p:spPr>
-          <a:xfrm>
-            <a:off x="9482328" y="2350008"/>
-            <a:ext cx="2295144" cy="246888"/>
-          </a:xfrm>
-          <a:prstGeom prst="rect">
-            <a:avLst/>
-          </a:prstGeom>
-          <a:noFill/>
-        </p:spPr>
-        <p:txBody>
-          <a:bodyPr wrap="square" lIns="36576" tIns="9144" rIns="36576" bIns="9144">
-            <a:spAutoFit/>
-          </a:bodyPr>
-          <a:lstStyle/>
-          <a:p>
-            <a:pPr>
-              <a:spcAft>
-                <a:spcPts val="100"/>
-              </a:spcAft>
-              <a:defRPr sz="1000" b="1">
-                <a:solidFill>
-                  <a:srgbClr val="9BB0C8"/>
-                </a:solidFill>
-                <a:latin typeface="Aptos"/>
-              </a:defRPr>
-            </a:pPr>
-            <a:r>
-              <a:t>FALSE POSITIVES</a:t>
-            </a:r>
-          </a:p>
-        </p:txBody>
-      </p:sp>
-      <p:sp>
-        <p:nvSpPr>
-          <p:cNvPr id="24" name="TextBox 23"/>
-          <p:cNvSpPr txBox="1"/>
-          <p:nvPr/>
-        </p:nvSpPr>
-        <p:spPr>
-          <a:xfrm>
-            <a:off x="9473184" y="2670048"/>
-            <a:ext cx="2295144" cy="530352"/>
-          </a:xfrm>
-          <a:prstGeom prst="rect">
-            <a:avLst/>
-          </a:prstGeom>
-          <a:noFill/>
-        </p:spPr>
-        <p:txBody>
-          <a:bodyPr wrap="square" lIns="36576" tIns="9144" rIns="36576" bIns="9144">
-            <a:spAutoFit/>
-          </a:bodyPr>
-          <a:lstStyle/>
-          <a:p>
-            <a:pPr>
-              <a:spcAft>
-                <a:spcPts val="100"/>
-              </a:spcAft>
-              <a:defRPr sz="2600" b="1">
-                <a:solidFill>
-                  <a:srgbClr val="85A9FF"/>
-                </a:solidFill>
-                <a:latin typeface="Aptos"/>
-              </a:defRPr>
-            </a:pPr>
-            <a:r>
-              <a:t>0</a:t>
-            </a:r>
-          </a:p>
-        </p:txBody>
-      </p:sp>
-      <p:sp>
-        <p:nvSpPr>
-          <p:cNvPr id="25" name="TextBox 24"/>
-          <p:cNvSpPr txBox="1"/>
-          <p:nvPr/>
-        </p:nvSpPr>
-        <p:spPr>
-          <a:xfrm>
-            <a:off x="9473184" y="3264408"/>
-            <a:ext cx="2295144" cy="630936"/>
-          </a:xfrm>
-          <a:prstGeom prst="rect">
-            <a:avLst/>
-          </a:prstGeom>
-          <a:noFill/>
-        </p:spPr>
-        <p:txBody>
-          <a:bodyPr wrap="square" lIns="36576" tIns="9144" rIns="36576" bIns="9144">
-            <a:spAutoFit/>
-          </a:bodyPr>
-          <a:lstStyle/>
-          <a:p>
-            <a:pPr>
-              <a:spcAft>
-                <a:spcPts val="100"/>
-              </a:spcAft>
-              <a:defRPr sz="1100" b="0">
-                <a:solidFill>
-                  <a:srgbClr val="EEF7FF"/>
-                </a:solidFill>
-                <a:latin typeface="Aptos"/>
-              </a:defRPr>
-            </a:pPr>
-            <a:r>
-              <a:t>held-out cases</a:t>
-            </a:r>
-          </a:p>
-        </p:txBody>
-      </p:sp>
-      <p:sp>
-        <p:nvSpPr>
-          <p:cNvPr id="26" name="Rounded Rectangle 25"/>
-          <p:cNvSpPr/>
-          <p:nvPr/>
-        </p:nvSpPr>
-        <p:spPr>
-          <a:xfrm>
-            <a:off x="685800" y="4343400"/>
-            <a:ext cx="10835640" cy="1389888"/>
+            <a:off x="704088" y="5294376"/>
+            <a:ext cx="10954512" cy="694944"/>
           </a:xfrm>
           <a:prstGeom prst="roundRect">
             <a:avLst/>
@@ -10573,70 +10608,31 @@
       </p:sp>
       <p:sp>
         <p:nvSpPr>
-          <p:cNvPr id="27" name="TextBox 26"/>
-          <p:cNvSpPr txBox="1"/>
-          <p:nvPr/>
-        </p:nvSpPr>
-        <p:spPr>
-          <a:xfrm>
-            <a:off x="886968" y="4626864"/>
-            <a:ext cx="10332720" cy="384048"/>
-          </a:xfrm>
-          <a:prstGeom prst="rect">
-            <a:avLst/>
-          </a:prstGeom>
-          <a:noFill/>
-        </p:spPr>
-        <p:txBody>
-          <a:bodyPr wrap="square" lIns="36576" tIns="9144" rIns="36576" bIns="9144">
-            <a:spAutoFit/>
-          </a:bodyPr>
-          <a:lstStyle/>
-          <a:p>
-            <a:pPr>
-              <a:spcAft>
-                <a:spcPts val="100"/>
-              </a:spcAft>
-              <a:defRPr sz="1700" b="1">
-                <a:solidFill>
-                  <a:srgbClr val="EEF7FF"/>
-                </a:solidFill>
-                <a:latin typeface="Aptos"/>
-              </a:defRPr>
-            </a:pPr>
-            <a:r>
-              <a:t>Forbidden protected executions: 0   •   Scripted control ASR: 33.3%   •   Protected ASR: 0.0%</a:t>
-            </a:r>
-          </a:p>
-        </p:txBody>
-      </p:sp>
-      <p:sp>
-        <p:nvSpPr>
-          <p:cNvPr id="28" name="TextBox 27"/>
-          <p:cNvSpPr txBox="1"/>
-          <p:nvPr/>
-        </p:nvSpPr>
-        <p:spPr>
-          <a:xfrm>
-            <a:off x="905256" y="5166360"/>
-            <a:ext cx="10168128" cy="429768"/>
-          </a:xfrm>
-          <a:prstGeom prst="rect">
-            <a:avLst/>
-          </a:prstGeom>
-          <a:noFill/>
-        </p:spPr>
-        <p:txBody>
-          <a:bodyPr wrap="square" lIns="36576" tIns="9144" rIns="36576" bIns="9144">
-            <a:spAutoFit/>
-          </a:bodyPr>
-          <a:lstStyle/>
-          <a:p>
-            <a:pPr>
-              <a:spcAft>
-                <a:spcPts val="100"/>
-              </a:spcAft>
-              <a:defRPr sz="1100" b="0">
+          <p:cNvPr id="26" name="TextBox 25"/>
+          <p:cNvSpPr txBox="1"/>
+          <p:nvPr/>
+        </p:nvSpPr>
+        <p:spPr>
+          <a:xfrm>
+            <a:off x="859536" y="5468112"/>
+            <a:ext cx="10570464" cy="429768"/>
+          </a:xfrm>
+          <a:prstGeom prst="rect">
+            <a:avLst/>
+          </a:prstGeom>
+          <a:noFill/>
+        </p:spPr>
+        <p:txBody>
+          <a:bodyPr wrap="square" lIns="36576" tIns="9144" rIns="36576" bIns="9144">
+            <a:spAutoFit/>
+          </a:bodyPr>
+          <a:lstStyle/>
+          <a:p>
+            <a:pPr>
+              <a:spcAft>
+                <a:spcPts val="100"/>
+              </a:spcAft>
+              <a:defRPr sz="1300" b="1">
                 <a:solidFill>
                   <a:srgbClr val="F1C174"/>
                 </a:solidFill>
@@ -10644,7 +10640,7 @@
               </a:defRPr>
             </a:pPr>
             <a:r>
-              <a:t>Important: The control is intentionally vulnerable scripted logic, NOT a measured real LLM. Dataset is templated; a perfect score does not prove security.</a:t>
+              <a:t>F3–D1 only. Template benchmark 45/45; newly frozen challenge misses 13/20 attacks. Zero forbidden mock tool actions.</a:t>
             </a:r>
           </a:p>
         </p:txBody>
@@ -10990,7 +10986,7 @@
               </a:defRPr>
             </a:pPr>
             <a:r>
-              <a:t>v1.2 · F3–D1 · SYNTHETIC SANDBOX</a:t>
+              <a:t>v1.4 · F3–D1 · SYNTHETIC SANDBOX</a:t>
             </a:r>
           </a:p>
         </p:txBody>
@@ -11724,7 +11720,7 @@
               </a:defRPr>
             </a:pPr>
             <a:r>
-              <a:t>v1.2 · F3–D1 · SYNTHETIC SANDBOX</a:t>
+              <a:t>v1.4 · F3–D1 · SYNTHETIC SANDBOX</a:t>
             </a:r>
           </a:p>
         </p:txBody>

</xml_diff>

<commit_message>
docs: publish v1.6 presentation and 2m27 narrated screenshot walkthrough
</commit_message>
<xml_diff>
--- a/submission/TrustBoundary_Hackathon_Pitch.pptx
+++ b/submission/TrustBoundary_Hackathon_Pitch.pptx
@@ -3420,7 +3420,7 @@
               </a:defRPr>
             </a:pPr>
             <a:r>
-              <a:t>v1.4 · F3–D1 · SYNTHETIC SANDBOX</a:t>
+              <a:t>v1.6 · F3–D1 · SYNTHETIC SANDBOX</a:t>
             </a:r>
           </a:p>
         </p:txBody>
@@ -4004,7 +4004,7 @@
               </a:defRPr>
             </a:pPr>
             <a:r>
-              <a:t>v1.4 · F3–D1 · SYNTHETIC SANDBOX</a:t>
+              <a:t>v1.6 · F3–D1 · SYNTHETIC SANDBOX</a:t>
             </a:r>
           </a:p>
         </p:txBody>
@@ -4246,7 +4246,7 @@
               </a:defRPr>
             </a:pPr>
             <a:r>
-              <a:t>Independent testing and live OpenAI evaluation; fresh 40-case recall only 35.0%.</a:t>
+              <a:t>Public external benchmark pending; live OpenAI unverified; new 40-case recall 35.0%.</a:t>
             </a:r>
           </a:p>
         </p:txBody>
@@ -4791,7 +4791,7 @@
               </a:defRPr>
             </a:pPr>
             <a:r>
-              <a:t>v1.4 · F3–D1 · SYNTHETIC SANDBOX</a:t>
+              <a:t>v1.6 · F3–D1 · SYNTHETIC SANDBOX</a:t>
             </a:r>
           </a:p>
         </p:txBody>
@@ -5656,7 +5656,7 @@
               </a:defRPr>
             </a:pPr>
             <a:r>
-              <a:t>v1.4 · F3–D1 · SYNTHETIC SANDBOX</a:t>
+              <a:t>v1.6 · F3–D1 · SYNTHETIC SANDBOX</a:t>
             </a:r>
           </a:p>
         </p:txBody>
@@ -6525,7 +6525,7 @@
               </a:defRPr>
             </a:pPr>
             <a:r>
-              <a:t>v1.4 · F3–D1 · SYNTHETIC SANDBOX</a:t>
+              <a:t>v1.6 · F3–D1 · SYNTHETIC SANDBOX</a:t>
             </a:r>
           </a:p>
         </p:txBody>
@@ -7056,7 +7056,7 @@
               </a:defRPr>
             </a:pPr>
             <a:r>
-              <a:t>v1.4 · F3–D1 · SYNTHETIC SANDBOX</a:t>
+              <a:t>v1.6 · F3–D1 · SYNTHETIC SANDBOX</a:t>
             </a:r>
           </a:p>
         </p:txBody>
@@ -8487,7 +8487,7 @@
               </a:defRPr>
             </a:pPr>
             <a:r>
-              <a:t>v1.4 · F3–D1 · SYNTHETIC SANDBOX</a:t>
+              <a:t>v1.6 · F3–D1 · SYNTHETIC SANDBOX</a:t>
             </a:r>
           </a:p>
         </p:txBody>
@@ -9961,7 +9961,7 @@
               </a:defRPr>
             </a:pPr>
             <a:r>
-              <a:t>v1.4 · F3–D1 · SYNTHETIC SANDBOX</a:t>
+              <a:t>v1.6 · F3–D1 · SYNTHETIC SANDBOX</a:t>
             </a:r>
           </a:p>
         </p:txBody>
@@ -10640,7 +10640,7 @@
               </a:defRPr>
             </a:pPr>
             <a:r>
-              <a:t>F3–D1 only. Template benchmark 45/45; newly frozen challenge misses 13/20 attacks. Zero forbidden mock tool actions.</a:t>
+              <a:t>F3–D1. Forty-case challenge misses 13/20 attacks; 50 benign emails have 2 false alerts; no external score claimed.</a:t>
             </a:r>
           </a:p>
         </p:txBody>
@@ -10986,7 +10986,7 @@
               </a:defRPr>
             </a:pPr>
             <a:r>
-              <a:t>v1.4 · F3–D1 · SYNTHETIC SANDBOX</a:t>
+              <a:t>v1.6 · F3–D1 · SYNTHETIC SANDBOX</a:t>
             </a:r>
           </a:p>
         </p:txBody>
@@ -11720,7 +11720,7 @@
               </a:defRPr>
             </a:pPr>
             <a:r>
-              <a:t>v1.4 · F3–D1 · SYNTHETIC SANDBOX</a:t>
+              <a:t>v1.6 · F3–D1 · SYNTHETIC SANDBOX</a:t>
             </a:r>
           </a:p>
         </p:txBody>

</xml_diff>

<commit_message>
Publish v1.7 updated pitch PowerPoint and PDF with measured evaluation
</commit_message>
<xml_diff>
--- a/submission/TrustBoundary_Hackathon_Pitch.pptx
+++ b/submission/TrustBoundary_Hackathon_Pitch.pptx
@@ -3420,7 +3420,7 @@
               </a:defRPr>
             </a:pPr>
             <a:r>
-              <a:t>v1.6 · F3–D1 · SYNTHETIC SANDBOX</a:t>
+              <a:t>v1.7 · F3–D1 · SYNTHETIC SANDBOX</a:t>
             </a:r>
           </a:p>
         </p:txBody>
@@ -4004,7 +4004,7 @@
               </a:defRPr>
             </a:pPr>
             <a:r>
-              <a:t>v1.6 · F3–D1 · SYNTHETIC SANDBOX</a:t>
+              <a:t>v1.7 · F3–D1 · SYNTHETIC SANDBOX</a:t>
             </a:r>
           </a:p>
         </p:txBody>
@@ -4246,7 +4246,7 @@
               </a:defRPr>
             </a:pPr>
             <a:r>
-              <a:t>Public external benchmark pending; live OpenAI unverified; new 40-case recall 35.0%.</a:t>
+              <a:t>Public external benchmark pending; live OpenAI unverified; new 40-case recall 50.0%.</a:t>
             </a:r>
           </a:p>
         </p:txBody>
@@ -4791,7 +4791,7 @@
               </a:defRPr>
             </a:pPr>
             <a:r>
-              <a:t>v1.6 · F3–D1 · SYNTHETIC SANDBOX</a:t>
+              <a:t>v1.7 · F3–D1 · SYNTHETIC SANDBOX</a:t>
             </a:r>
           </a:p>
         </p:txBody>
@@ -5656,7 +5656,7 @@
               </a:defRPr>
             </a:pPr>
             <a:r>
-              <a:t>v1.6 · F3–D1 · SYNTHETIC SANDBOX</a:t>
+              <a:t>v1.7 · F3–D1 · SYNTHETIC SANDBOX</a:t>
             </a:r>
           </a:p>
         </p:txBody>
@@ -6404,7 +6404,7 @@
               </a:defRPr>
             </a:pPr>
             <a:r>
-              <a:t>Same user task, same untrusted message, different tool authorization outcomes.</a:t>
+              <a:t>Independent tool gate protects user task even when classification misses.</a:t>
             </a:r>
           </a:p>
         </p:txBody>
@@ -6525,7 +6525,7 @@
               </a:defRPr>
             </a:pPr>
             <a:r>
-              <a:t>v1.6 · F3–D1 · SYNTHETIC SANDBOX</a:t>
+              <a:t>v1.7 · F3–D1 · SYNTHETIC SANDBOX</a:t>
             </a:r>
           </a:p>
         </p:txBody>
@@ -6671,7 +6671,7 @@
               </a:defRPr>
             </a:pPr>
             <a:r>
-              <a:t>Insecure scripted control follows the injected refund request.</a:t>
+              <a:t>Scripted control is illustrative, not a measured attacked LLM.</a:t>
             </a:r>
           </a:p>
         </p:txBody>
@@ -7056,7 +7056,7 @@
               </a:defRPr>
             </a:pPr>
             <a:r>
-              <a:t>v1.6 · F3–D1 · SYNTHETIC SANDBOX</a:t>
+              <a:t>v1.7 · F3–D1 · SYNTHETIC SANDBOX</a:t>
             </a:r>
           </a:p>
         </p:txBody>
@@ -7337,7 +7337,7 @@
               </a:defRPr>
             </a:pPr>
             <a:r>
-              <a:t>email · HTML · PDF · API</a:t>
+              <a:t>email · Word · OCR · HTML · API</a:t>
             </a:r>
           </a:p>
         </p:txBody>
@@ -7497,7 +7497,7 @@
               </a:defRPr>
             </a:pPr>
             <a:r>
-              <a:t>local ML + rules + optional LLM</a:t>
+              <a:t>rules + structural signals + ML + optional LLM judge</a:t>
             </a:r>
           </a:p>
         </p:txBody>
@@ -8487,7 +8487,7 @@
               </a:defRPr>
             </a:pPr>
             <a:r>
-              <a:t>v1.6 · F3–D1 · SYNTHETIC SANDBOX</a:t>
+              <a:t>v1.7 · F3–D1 · SYNTHETIC SANDBOX</a:t>
             </a:r>
           </a:p>
         </p:txBody>
@@ -9961,7 +9961,7 @@
               </a:defRPr>
             </a:pPr>
             <a:r>
-              <a:t>v1.6 · F3–D1 · SYNTHETIC SANDBOX</a:t>
+              <a:t>v1.7 · F3–D1 · SYNTHETIC SANDBOX</a:t>
             </a:r>
           </a:p>
         </p:txBody>
@@ -10441,7 +10441,7 @@
               </a:defRPr>
             </a:pPr>
             <a:r>
-              <a:t>NEW CHALLENGE</a:t>
+              <a:t>KNOWN 40-CASE SET</a:t>
             </a:r>
           </a:p>
         </p:txBody>
@@ -10480,7 +10480,7 @@
               </a:defRPr>
             </a:pPr>
             <a:r>
-              <a:t>35.0%</a:t>
+              <a:t>50.0%</a:t>
             </a:r>
           </a:p>
         </p:txBody>
@@ -10519,7 +10519,7 @@
               </a:defRPr>
             </a:pPr>
             <a:r>
-              <a:t>7 / 20 attacks detected</a:t>
+              <a:t>10 / 20 attacks detected</a:t>
             </a:r>
           </a:p>
         </p:txBody>
@@ -10558,7 +10558,7 @@
               </a:defRPr>
             </a:pPr>
             <a:r>
-              <a:t>40 new authored cases; 1 benign FP</a:t>
+              <a:t>40 previously reviewed cases; 2 benign FP</a:t>
             </a:r>
           </a:p>
         </p:txBody>
@@ -10640,7 +10640,7 @@
               </a:defRPr>
             </a:pPr>
             <a:r>
-              <a:t>F3–D1. Forty-case challenge misses 13/20 attacks; 50 benign emails have 2 false alerts; no external score claimed.</a:t>
+              <a:t>F3–D1. Known 40-case challenge misses 10/20 attacks; v1.7 judge feedback set is 28/30 (NOT blind). No live hosted score.</a:t>
             </a:r>
           </a:p>
         </p:txBody>
@@ -10986,7 +10986,7 @@
               </a:defRPr>
             </a:pPr>
             <a:r>
-              <a:t>v1.6 · F3–D1 · SYNTHETIC SANDBOX</a:t>
+              <a:t>v1.7 · F3–D1 · SYNTHETIC SANDBOX</a:t>
             </a:r>
           </a:p>
         </p:txBody>
@@ -11720,7 +11720,7 @@
               </a:defRPr>
             </a:pPr>
             <a:r>
-              <a:t>v1.6 · F3–D1 · SYNTHETIC SANDBOX</a:t>
+              <a:t>v1.7 · F3–D1 · SYNTHETIC SANDBOX</a:t>
             </a:r>
           </a:p>
         </p:txBody>

</xml_diff>